<commit_message>
feat(dm,script-runner): suspend auto-rest during runs and improve state/error visibility
</commit_message>
<xml_diff>
--- a/py3_script_runner/assets/presentations/Demo NAO Studio.pptx
+++ b/py3_script_runner/assets/presentations/Demo NAO Studio.pptx
@@ -7,6 +7,7 @@
   <p:sldIdLst>
     <p:sldId id="256" r:id="rId2"/>
     <p:sldId id="257" r:id="rId3"/>
+    <p:sldId id="259" r:id="rId4"/>
   </p:sldIdLst>
   <p:sldSz cx="12192000" cy="6858000"/>
   <p:notesSz cx="6858000" cy="9144000"/>
@@ -105,6 +106,11 @@
       </a:defRPr>
     </a:lvl9pPr>
   </p:defaultTextStyle>
+  <p:extLst>
+    <p:ext uri="{EFAFB233-063F-42B5-8137-9DF3F51BA10A}">
+      <p15:sldGuideLst xmlns:p15="http://schemas.microsoft.com/office/powerpoint/2012/main"/>
+    </p:ext>
+  </p:extLst>
 </p:presentation>
 </file>
 
@@ -158,7 +164,7 @@
           <a:noFill/>
           <a:extLst>
             <a:ext uri="{909E8E84-426E-40dd-AFC4-6F175D3DCCD1}">
-              <a14:hiddenFill xmlns:a14="http://schemas.microsoft.com/office/drawing/2010/main" xmlns="">
+              <a14:hiddenFill xmlns="" xmlns:a14="http://schemas.microsoft.com/office/drawing/2010/main">
                 <a:solidFill>
                   <a:srgbClr val="FFFFFF"/>
                 </a:solidFill>
@@ -218,7 +224,7 @@
             </a:ln>
             <a:extLst>
               <a:ext uri="{91240B29-F687-4f45-9708-019B960494DF}">
-                <a14:hiddenLine xmlns:a14="http://schemas.microsoft.com/office/drawing/2010/main" xmlns="" w="9525">
+                <a14:hiddenLine xmlns="" xmlns:a14="http://schemas.microsoft.com/office/drawing/2010/main" w="9525">
                   <a:solidFill>
                     <a:srgbClr val="000000"/>
                   </a:solidFill>
@@ -315,7 +321,7 @@
             </a:ln>
             <a:extLst>
               <a:ext uri="{91240B29-F687-4f45-9708-019B960494DF}">
-                <a14:hiddenLine xmlns:a14="http://schemas.microsoft.com/office/drawing/2010/main" xmlns="" w="9525">
+                <a14:hiddenLine xmlns="" xmlns:a14="http://schemas.microsoft.com/office/drawing/2010/main" w="9525">
                   <a:solidFill>
                     <a:srgbClr val="000000"/>
                   </a:solidFill>
@@ -412,7 +418,7 @@
             </a:ln>
             <a:extLst>
               <a:ext uri="{91240B29-F687-4f45-9708-019B960494DF}">
-                <a14:hiddenLine xmlns:a14="http://schemas.microsoft.com/office/drawing/2010/main" xmlns="" w="9525">
+                <a14:hiddenLine xmlns="" xmlns:a14="http://schemas.microsoft.com/office/drawing/2010/main" w="9525">
                   <a:solidFill>
                     <a:srgbClr val="000000"/>
                   </a:solidFill>
@@ -453,7 +459,7 @@
             </a:ln>
             <a:extLst>
               <a:ext uri="{91240B29-F687-4f45-9708-019B960494DF}">
-                <a14:hiddenLine xmlns:a14="http://schemas.microsoft.com/office/drawing/2010/main" xmlns="" w="9525">
+                <a14:hiddenLine xmlns="" xmlns:a14="http://schemas.microsoft.com/office/drawing/2010/main" w="9525">
                   <a:solidFill>
                     <a:srgbClr val="000000"/>
                   </a:solidFill>
@@ -550,7 +556,7 @@
             </a:ln>
             <a:extLst>
               <a:ext uri="{91240B29-F687-4f45-9708-019B960494DF}">
-                <a14:hiddenLine xmlns:a14="http://schemas.microsoft.com/office/drawing/2010/main" xmlns="" w="9525">
+                <a14:hiddenLine xmlns="" xmlns:a14="http://schemas.microsoft.com/office/drawing/2010/main" w="9525">
                   <a:solidFill>
                     <a:srgbClr val="000000"/>
                   </a:solidFill>
@@ -619,7 +625,7 @@
             </a:ln>
             <a:extLst>
               <a:ext uri="{91240B29-F687-4f45-9708-019B960494DF}">
-                <a14:hiddenLine xmlns:a14="http://schemas.microsoft.com/office/drawing/2010/main" xmlns="" w="9525">
+                <a14:hiddenLine xmlns="" xmlns:a14="http://schemas.microsoft.com/office/drawing/2010/main" w="9525">
                   <a:solidFill>
                     <a:srgbClr val="000000"/>
                   </a:solidFill>
@@ -688,7 +694,7 @@
             </a:ln>
             <a:extLst>
               <a:ext uri="{91240B29-F687-4f45-9708-019B960494DF}">
-                <a14:hiddenLine xmlns:a14="http://schemas.microsoft.com/office/drawing/2010/main" xmlns="" w="9525">
+                <a14:hiddenLine xmlns="" xmlns:a14="http://schemas.microsoft.com/office/drawing/2010/main" w="9525">
                   <a:solidFill>
                     <a:srgbClr val="000000"/>
                   </a:solidFill>
@@ -785,7 +791,7 @@
             </a:ln>
             <a:extLst>
               <a:ext uri="{91240B29-F687-4f45-9708-019B960494DF}">
-                <a14:hiddenLine xmlns:a14="http://schemas.microsoft.com/office/drawing/2010/main" xmlns="" w="9525">
+                <a14:hiddenLine xmlns="" xmlns:a14="http://schemas.microsoft.com/office/drawing/2010/main" w="9525">
                   <a:solidFill>
                     <a:srgbClr val="000000"/>
                   </a:solidFill>
@@ -854,7 +860,7 @@
             </a:ln>
             <a:extLst>
               <a:ext uri="{91240B29-F687-4f45-9708-019B960494DF}">
-                <a14:hiddenLine xmlns:a14="http://schemas.microsoft.com/office/drawing/2010/main" xmlns="" w="9525">
+                <a14:hiddenLine xmlns="" xmlns:a14="http://schemas.microsoft.com/office/drawing/2010/main" w="9525">
                   <a:solidFill>
                     <a:srgbClr val="000000"/>
                   </a:solidFill>
@@ -923,7 +929,7 @@
             </a:ln>
             <a:extLst>
               <a:ext uri="{91240B29-F687-4f45-9708-019B960494DF}">
-                <a14:hiddenLine xmlns:a14="http://schemas.microsoft.com/office/drawing/2010/main" xmlns="" w="9525">
+                <a14:hiddenLine xmlns="" xmlns:a14="http://schemas.microsoft.com/office/drawing/2010/main" w="9525">
                   <a:solidFill>
                     <a:srgbClr val="000000"/>
                   </a:solidFill>
@@ -1020,7 +1026,7 @@
             </a:ln>
             <a:extLst>
               <a:ext uri="{91240B29-F687-4f45-9708-019B960494DF}">
-                <a14:hiddenLine xmlns:a14="http://schemas.microsoft.com/office/drawing/2010/main" xmlns="" w="9525">
+                <a14:hiddenLine xmlns="" xmlns:a14="http://schemas.microsoft.com/office/drawing/2010/main" w="9525">
                   <a:solidFill>
                     <a:srgbClr val="000000"/>
                   </a:solidFill>
@@ -1117,7 +1123,7 @@
             </a:ln>
             <a:extLst>
               <a:ext uri="{91240B29-F687-4f45-9708-019B960494DF}">
-                <a14:hiddenLine xmlns:a14="http://schemas.microsoft.com/office/drawing/2010/main" xmlns="" w="9525">
+                <a14:hiddenLine xmlns="" xmlns:a14="http://schemas.microsoft.com/office/drawing/2010/main" w="9525">
                   <a:solidFill>
                     <a:srgbClr val="000000"/>
                   </a:solidFill>
@@ -1186,7 +1192,7 @@
             </a:ln>
             <a:extLst>
               <a:ext uri="{91240B29-F687-4f45-9708-019B960494DF}">
-                <a14:hiddenLine xmlns:a14="http://schemas.microsoft.com/office/drawing/2010/main" xmlns="" w="9525">
+                <a14:hiddenLine xmlns="" xmlns:a14="http://schemas.microsoft.com/office/drawing/2010/main" w="9525">
                   <a:solidFill>
                     <a:srgbClr val="000000"/>
                   </a:solidFill>
@@ -1303,7 +1309,7 @@
             </a:ln>
             <a:extLst>
               <a:ext uri="{91240B29-F687-4f45-9708-019B960494DF}">
-                <a14:hiddenLine xmlns:a14="http://schemas.microsoft.com/office/drawing/2010/main" xmlns="" w="9525">
+                <a14:hiddenLine xmlns="" xmlns:a14="http://schemas.microsoft.com/office/drawing/2010/main" w="9525">
                   <a:solidFill>
                     <a:srgbClr val="000000"/>
                   </a:solidFill>
@@ -1372,7 +1378,7 @@
             </a:ln>
             <a:extLst>
               <a:ext uri="{91240B29-F687-4f45-9708-019B960494DF}">
-                <a14:hiddenLine xmlns:a14="http://schemas.microsoft.com/office/drawing/2010/main" xmlns="" w="9525">
+                <a14:hiddenLine xmlns="" xmlns:a14="http://schemas.microsoft.com/office/drawing/2010/main" w="9525">
                   <a:solidFill>
                     <a:srgbClr val="000000"/>
                   </a:solidFill>
@@ -1469,7 +1475,7 @@
             </a:ln>
             <a:extLst>
               <a:ext uri="{91240B29-F687-4f45-9708-019B960494DF}">
-                <a14:hiddenLine xmlns:a14="http://schemas.microsoft.com/office/drawing/2010/main" xmlns="" w="9525">
+                <a14:hiddenLine xmlns="" xmlns:a14="http://schemas.microsoft.com/office/drawing/2010/main" w="9525">
                   <a:solidFill>
                     <a:srgbClr val="000000"/>
                   </a:solidFill>
@@ -1566,7 +1572,7 @@
             </a:ln>
             <a:extLst>
               <a:ext uri="{91240B29-F687-4f45-9708-019B960494DF}">
-                <a14:hiddenLine xmlns:a14="http://schemas.microsoft.com/office/drawing/2010/main" xmlns="" w="9525">
+                <a14:hiddenLine xmlns="" xmlns:a14="http://schemas.microsoft.com/office/drawing/2010/main" w="9525">
                   <a:solidFill>
                     <a:srgbClr val="000000"/>
                   </a:solidFill>
@@ -1635,7 +1641,7 @@
             </a:ln>
             <a:extLst>
               <a:ext uri="{91240B29-F687-4f45-9708-019B960494DF}">
-                <a14:hiddenLine xmlns:a14="http://schemas.microsoft.com/office/drawing/2010/main" xmlns="" w="9525">
+                <a14:hiddenLine xmlns="" xmlns:a14="http://schemas.microsoft.com/office/drawing/2010/main" w="9525">
                   <a:solidFill>
                     <a:srgbClr val="000000"/>
                   </a:solidFill>
@@ -1732,7 +1738,7 @@
             </a:ln>
             <a:extLst>
               <a:ext uri="{91240B29-F687-4f45-9708-019B960494DF}">
-                <a14:hiddenLine xmlns:a14="http://schemas.microsoft.com/office/drawing/2010/main" xmlns="" w="9525">
+                <a14:hiddenLine xmlns="" xmlns:a14="http://schemas.microsoft.com/office/drawing/2010/main" w="9525">
                   <a:solidFill>
                     <a:srgbClr val="000000"/>
                   </a:solidFill>
@@ -1829,7 +1835,7 @@
             </a:ln>
             <a:extLst>
               <a:ext uri="{91240B29-F687-4f45-9708-019B960494DF}">
-                <a14:hiddenLine xmlns:a14="http://schemas.microsoft.com/office/drawing/2010/main" xmlns="" w="9525">
+                <a14:hiddenLine xmlns="" xmlns:a14="http://schemas.microsoft.com/office/drawing/2010/main" w="9525">
                   <a:solidFill>
                     <a:srgbClr val="000000"/>
                   </a:solidFill>
@@ -1892,7 +1898,7 @@
             </a:ln>
             <a:extLst>
               <a:ext uri="{91240B29-F687-4f45-9708-019B960494DF}">
-                <a14:hiddenLine xmlns:a14="http://schemas.microsoft.com/office/drawing/2010/main" xmlns="" w="9525">
+                <a14:hiddenLine xmlns="" xmlns:a14="http://schemas.microsoft.com/office/drawing/2010/main" w="9525">
                   <a:solidFill>
                     <a:srgbClr val="000000"/>
                   </a:solidFill>
@@ -1989,7 +1995,7 @@
             </a:ln>
             <a:extLst>
               <a:ext uri="{91240B29-F687-4f45-9708-019B960494DF}">
-                <a14:hiddenLine xmlns:a14="http://schemas.microsoft.com/office/drawing/2010/main" xmlns="" w="9525">
+                <a14:hiddenLine xmlns="" xmlns:a14="http://schemas.microsoft.com/office/drawing/2010/main" w="9525">
                   <a:solidFill>
                     <a:srgbClr val="000000"/>
                   </a:solidFill>
@@ -2052,7 +2058,7 @@
             </a:ln>
             <a:extLst>
               <a:ext uri="{91240B29-F687-4f45-9708-019B960494DF}">
-                <a14:hiddenLine xmlns:a14="http://schemas.microsoft.com/office/drawing/2010/main" xmlns="" w="9525">
+                <a14:hiddenLine xmlns="" xmlns:a14="http://schemas.microsoft.com/office/drawing/2010/main" w="9525">
                   <a:solidFill>
                     <a:srgbClr val="000000"/>
                   </a:solidFill>
@@ -2149,7 +2155,7 @@
             </a:ln>
             <a:extLst>
               <a:ext uri="{91240B29-F687-4f45-9708-019B960494DF}">
-                <a14:hiddenLine xmlns:a14="http://schemas.microsoft.com/office/drawing/2010/main" xmlns="" w="9525">
+                <a14:hiddenLine xmlns="" xmlns:a14="http://schemas.microsoft.com/office/drawing/2010/main" w="9525">
                   <a:solidFill>
                     <a:srgbClr val="000000"/>
                   </a:solidFill>
@@ -2224,7 +2230,7 @@
             </a:ln>
             <a:extLst>
               <a:ext uri="{91240B29-F687-4f45-9708-019B960494DF}">
-                <a14:hiddenLine xmlns:a14="http://schemas.microsoft.com/office/drawing/2010/main" xmlns="" w="9525">
+                <a14:hiddenLine xmlns="" xmlns:a14="http://schemas.microsoft.com/office/drawing/2010/main" w="9525">
                   <a:solidFill>
                     <a:srgbClr val="000000"/>
                   </a:solidFill>
@@ -2321,7 +2327,7 @@
             </a:ln>
             <a:extLst>
               <a:ext uri="{91240B29-F687-4f45-9708-019B960494DF}">
-                <a14:hiddenLine xmlns:a14="http://schemas.microsoft.com/office/drawing/2010/main" xmlns="" w="9525">
+                <a14:hiddenLine xmlns="" xmlns:a14="http://schemas.microsoft.com/office/drawing/2010/main" w="9525">
                   <a:solidFill>
                     <a:srgbClr val="000000"/>
                   </a:solidFill>
@@ -2396,7 +2402,7 @@
             </a:ln>
             <a:extLst>
               <a:ext uri="{91240B29-F687-4f45-9708-019B960494DF}">
-                <a14:hiddenLine xmlns:a14="http://schemas.microsoft.com/office/drawing/2010/main" xmlns="" w="9525">
+                <a14:hiddenLine xmlns="" xmlns:a14="http://schemas.microsoft.com/office/drawing/2010/main" w="9525">
                   <a:solidFill>
                     <a:srgbClr val="000000"/>
                   </a:solidFill>
@@ -2493,7 +2499,7 @@
             </a:ln>
             <a:extLst>
               <a:ext uri="{91240B29-F687-4f45-9708-019B960494DF}">
-                <a14:hiddenLine xmlns:a14="http://schemas.microsoft.com/office/drawing/2010/main" xmlns="" w="9525">
+                <a14:hiddenLine xmlns="" xmlns:a14="http://schemas.microsoft.com/office/drawing/2010/main" w="9525">
                   <a:solidFill>
                     <a:srgbClr val="000000"/>
                   </a:solidFill>
@@ -2534,7 +2540,7 @@
             </a:ln>
             <a:extLst>
               <a:ext uri="{91240B29-F687-4f45-9708-019B960494DF}">
-                <a14:hiddenLine xmlns:a14="http://schemas.microsoft.com/office/drawing/2010/main" xmlns="" w="9525">
+                <a14:hiddenLine xmlns="" xmlns:a14="http://schemas.microsoft.com/office/drawing/2010/main" w="9525">
                   <a:solidFill>
                     <a:srgbClr val="000000"/>
                   </a:solidFill>
@@ -2631,7 +2637,7 @@
             </a:ln>
             <a:extLst>
               <a:ext uri="{91240B29-F687-4f45-9708-019B960494DF}">
-                <a14:hiddenLine xmlns:a14="http://schemas.microsoft.com/office/drawing/2010/main" xmlns="" w="9525">
+                <a14:hiddenLine xmlns="" xmlns:a14="http://schemas.microsoft.com/office/drawing/2010/main" w="9525">
                   <a:solidFill>
                     <a:srgbClr val="000000"/>
                   </a:solidFill>
@@ -2700,7 +2706,7 @@
             </a:ln>
             <a:extLst>
               <a:ext uri="{91240B29-F687-4f45-9708-019B960494DF}">
-                <a14:hiddenLine xmlns:a14="http://schemas.microsoft.com/office/drawing/2010/main" xmlns="" w="9525">
+                <a14:hiddenLine xmlns="" xmlns:a14="http://schemas.microsoft.com/office/drawing/2010/main" w="9525">
                   <a:solidFill>
                     <a:srgbClr val="000000"/>
                   </a:solidFill>
@@ -2769,7 +2775,7 @@
             </a:ln>
             <a:extLst>
               <a:ext uri="{91240B29-F687-4f45-9708-019B960494DF}">
-                <a14:hiddenLine xmlns:a14="http://schemas.microsoft.com/office/drawing/2010/main" xmlns="" w="9525">
+                <a14:hiddenLine xmlns="" xmlns:a14="http://schemas.microsoft.com/office/drawing/2010/main" w="9525">
                   <a:solidFill>
                     <a:srgbClr val="000000"/>
                   </a:solidFill>
@@ -2866,7 +2872,7 @@
             </a:ln>
             <a:extLst>
               <a:ext uri="{91240B29-F687-4f45-9708-019B960494DF}">
-                <a14:hiddenLine xmlns:a14="http://schemas.microsoft.com/office/drawing/2010/main" xmlns="" w="9525">
+                <a14:hiddenLine xmlns="" xmlns:a14="http://schemas.microsoft.com/office/drawing/2010/main" w="9525">
                   <a:solidFill>
                     <a:srgbClr val="000000"/>
                   </a:solidFill>
@@ -2941,7 +2947,7 @@
             </a:ln>
             <a:extLst>
               <a:ext uri="{91240B29-F687-4f45-9708-019B960494DF}">
-                <a14:hiddenLine xmlns:a14="http://schemas.microsoft.com/office/drawing/2010/main" xmlns="" w="9525">
+                <a14:hiddenLine xmlns="" xmlns:a14="http://schemas.microsoft.com/office/drawing/2010/main" w="9525">
                   <a:solidFill>
                     <a:srgbClr val="000000"/>
                   </a:solidFill>
@@ -3010,7 +3016,7 @@
             </a:ln>
             <a:extLst>
               <a:ext uri="{91240B29-F687-4f45-9708-019B960494DF}">
-                <a14:hiddenLine xmlns:a14="http://schemas.microsoft.com/office/drawing/2010/main" xmlns="" w="9525">
+                <a14:hiddenLine xmlns="" xmlns:a14="http://schemas.microsoft.com/office/drawing/2010/main" w="9525">
                   <a:solidFill>
                     <a:srgbClr val="000000"/>
                   </a:solidFill>
@@ -3107,7 +3113,7 @@
             </a:ln>
             <a:extLst>
               <a:ext uri="{91240B29-F687-4f45-9708-019B960494DF}">
-                <a14:hiddenLine xmlns:a14="http://schemas.microsoft.com/office/drawing/2010/main" xmlns="" w="9525">
+                <a14:hiddenLine xmlns="" xmlns:a14="http://schemas.microsoft.com/office/drawing/2010/main" w="9525">
                   <a:solidFill>
                     <a:srgbClr val="000000"/>
                   </a:solidFill>
@@ -3176,7 +3182,7 @@
             </a:ln>
             <a:extLst>
               <a:ext uri="{91240B29-F687-4f45-9708-019B960494DF}">
-                <a14:hiddenLine xmlns:a14="http://schemas.microsoft.com/office/drawing/2010/main" xmlns="" w="9525">
+                <a14:hiddenLine xmlns="" xmlns:a14="http://schemas.microsoft.com/office/drawing/2010/main" w="9525">
                   <a:solidFill>
                     <a:srgbClr val="000000"/>
                   </a:solidFill>
@@ -3273,7 +3279,7 @@
             </a:ln>
             <a:extLst>
               <a:ext uri="{91240B29-F687-4f45-9708-019B960494DF}">
-                <a14:hiddenLine xmlns:a14="http://schemas.microsoft.com/office/drawing/2010/main" xmlns="" w="9525">
+                <a14:hiddenLine xmlns="" xmlns:a14="http://schemas.microsoft.com/office/drawing/2010/main" w="9525">
                   <a:solidFill>
                     <a:srgbClr val="000000"/>
                   </a:solidFill>
@@ -3342,7 +3348,7 @@
             </a:ln>
             <a:extLst>
               <a:ext uri="{91240B29-F687-4f45-9708-019B960494DF}">
-                <a14:hiddenLine xmlns:a14="http://schemas.microsoft.com/office/drawing/2010/main" xmlns="" w="9525">
+                <a14:hiddenLine xmlns="" xmlns:a14="http://schemas.microsoft.com/office/drawing/2010/main" w="9525">
                   <a:solidFill>
                     <a:srgbClr val="000000"/>
                   </a:solidFill>
@@ -3439,7 +3445,7 @@
             </a:ln>
             <a:extLst>
               <a:ext uri="{91240B29-F687-4f45-9708-019B960494DF}">
-                <a14:hiddenLine xmlns:a14="http://schemas.microsoft.com/office/drawing/2010/main" xmlns="" w="9525">
+                <a14:hiddenLine xmlns="" xmlns:a14="http://schemas.microsoft.com/office/drawing/2010/main" w="9525">
                   <a:solidFill>
                     <a:srgbClr val="000000"/>
                   </a:solidFill>
@@ -3480,7 +3486,7 @@
             </a:ln>
             <a:extLst>
               <a:ext uri="{91240B29-F687-4f45-9708-019B960494DF}">
-                <a14:hiddenLine xmlns:a14="http://schemas.microsoft.com/office/drawing/2010/main" xmlns="" w="9525">
+                <a14:hiddenLine xmlns="" xmlns:a14="http://schemas.microsoft.com/office/drawing/2010/main" w="9525">
                   <a:solidFill>
                     <a:srgbClr val="000000"/>
                   </a:solidFill>
@@ -3552,7 +3558,7 @@
             </a:ln>
             <a:extLst>
               <a:ext uri="{91240B29-F687-4f45-9708-019B960494DF}">
-                <a14:hiddenLine xmlns:a14="http://schemas.microsoft.com/office/drawing/2010/main" xmlns="" w="9525">
+                <a14:hiddenLine xmlns="" xmlns:a14="http://schemas.microsoft.com/office/drawing/2010/main" w="9525">
                   <a:solidFill>
                     <a:srgbClr val="000000"/>
                   </a:solidFill>
@@ -3649,7 +3655,7 @@
             </a:ln>
             <a:extLst>
               <a:ext uri="{91240B29-F687-4f45-9708-019B960494DF}">
-                <a14:hiddenLine xmlns:a14="http://schemas.microsoft.com/office/drawing/2010/main" xmlns="" w="9525">
+                <a14:hiddenLine xmlns="" xmlns:a14="http://schemas.microsoft.com/office/drawing/2010/main" w="9525">
                   <a:solidFill>
                     <a:srgbClr val="000000"/>
                   </a:solidFill>
@@ -3718,7 +3724,7 @@
             </a:ln>
             <a:extLst>
               <a:ext uri="{91240B29-F687-4f45-9708-019B960494DF}">
-                <a14:hiddenLine xmlns:a14="http://schemas.microsoft.com/office/drawing/2010/main" xmlns="" w="9525">
+                <a14:hiddenLine xmlns="" xmlns:a14="http://schemas.microsoft.com/office/drawing/2010/main" w="9525">
                   <a:solidFill>
                     <a:srgbClr val="000000"/>
                   </a:solidFill>
@@ -3815,7 +3821,7 @@
             </a:ln>
             <a:extLst>
               <a:ext uri="{91240B29-F687-4f45-9708-019B960494DF}">
-                <a14:hiddenLine xmlns:a14="http://schemas.microsoft.com/office/drawing/2010/main" xmlns="" w="9525">
+                <a14:hiddenLine xmlns="" xmlns:a14="http://schemas.microsoft.com/office/drawing/2010/main" w="9525">
                   <a:solidFill>
                     <a:srgbClr val="000000"/>
                   </a:solidFill>
@@ -3912,7 +3918,7 @@
             </a:ln>
             <a:extLst>
               <a:ext uri="{91240B29-F687-4f45-9708-019B960494DF}">
-                <a14:hiddenLine xmlns:a14="http://schemas.microsoft.com/office/drawing/2010/main" xmlns="" w="9525">
+                <a14:hiddenLine xmlns="" xmlns:a14="http://schemas.microsoft.com/office/drawing/2010/main" w="9525">
                   <a:solidFill>
                     <a:srgbClr val="000000"/>
                   </a:solidFill>
@@ -3984,7 +3990,7 @@
             </a:ln>
             <a:extLst>
               <a:ext uri="{91240B29-F687-4f45-9708-019B960494DF}">
-                <a14:hiddenLine xmlns:a14="http://schemas.microsoft.com/office/drawing/2010/main" xmlns="" w="9525">
+                <a14:hiddenLine xmlns="" xmlns:a14="http://schemas.microsoft.com/office/drawing/2010/main" w="9525">
                   <a:solidFill>
                     <a:srgbClr val="000000"/>
                   </a:solidFill>
@@ -4053,7 +4059,7 @@
             </a:ln>
             <a:extLst>
               <a:ext uri="{91240B29-F687-4f45-9708-019B960494DF}">
-                <a14:hiddenLine xmlns:a14="http://schemas.microsoft.com/office/drawing/2010/main" xmlns="" w="9525">
+                <a14:hiddenLine xmlns="" xmlns:a14="http://schemas.microsoft.com/office/drawing/2010/main" w="9525">
                   <a:solidFill>
                     <a:srgbClr val="000000"/>
                   </a:solidFill>
@@ -4150,7 +4156,7 @@
             </a:ln>
             <a:extLst>
               <a:ext uri="{91240B29-F687-4f45-9708-019B960494DF}">
-                <a14:hiddenLine xmlns:a14="http://schemas.microsoft.com/office/drawing/2010/main" xmlns="" w="9525">
+                <a14:hiddenLine xmlns="" xmlns:a14="http://schemas.microsoft.com/office/drawing/2010/main" w="9525">
                   <a:solidFill>
                     <a:srgbClr val="000000"/>
                   </a:solidFill>
@@ -4247,7 +4253,7 @@
             </a:ln>
             <a:extLst>
               <a:ext uri="{91240B29-F687-4f45-9708-019B960494DF}">
-                <a14:hiddenLine xmlns:a14="http://schemas.microsoft.com/office/drawing/2010/main" xmlns="" w="9525">
+                <a14:hiddenLine xmlns="" xmlns:a14="http://schemas.microsoft.com/office/drawing/2010/main" w="9525">
                   <a:solidFill>
                     <a:srgbClr val="000000"/>
                   </a:solidFill>
@@ -4316,7 +4322,7 @@
             </a:ln>
             <a:extLst>
               <a:ext uri="{91240B29-F687-4f45-9708-019B960494DF}">
-                <a14:hiddenLine xmlns:a14="http://schemas.microsoft.com/office/drawing/2010/main" xmlns="" w="9525">
+                <a14:hiddenLine xmlns="" xmlns:a14="http://schemas.microsoft.com/office/drawing/2010/main" w="9525">
                   <a:solidFill>
                     <a:srgbClr val="000000"/>
                   </a:solidFill>
@@ -4443,7 +4449,7 @@
             </a:ln>
             <a:extLst>
               <a:ext uri="{91240B29-F687-4f45-9708-019B960494DF}">
-                <a14:hiddenLine xmlns:a14="http://schemas.microsoft.com/office/drawing/2010/main" xmlns="" w="9525">
+                <a14:hiddenLine xmlns="" xmlns:a14="http://schemas.microsoft.com/office/drawing/2010/main" w="9525">
                   <a:solidFill>
                     <a:srgbClr val="000000"/>
                   </a:solidFill>
@@ -4518,7 +4524,7 @@
             </a:ln>
             <a:extLst>
               <a:ext uri="{91240B29-F687-4f45-9708-019B960494DF}">
-                <a14:hiddenLine xmlns:a14="http://schemas.microsoft.com/office/drawing/2010/main" xmlns="" w="9525">
+                <a14:hiddenLine xmlns="" xmlns:a14="http://schemas.microsoft.com/office/drawing/2010/main" w="9525">
                   <a:solidFill>
                     <a:srgbClr val="000000"/>
                   </a:solidFill>
@@ -4615,7 +4621,7 @@
             </a:ln>
             <a:extLst>
               <a:ext uri="{91240B29-F687-4f45-9708-019B960494DF}">
-                <a14:hiddenLine xmlns:a14="http://schemas.microsoft.com/office/drawing/2010/main" xmlns="" w="9525">
+                <a14:hiddenLine xmlns="" xmlns:a14="http://schemas.microsoft.com/office/drawing/2010/main" w="9525">
                   <a:solidFill>
                     <a:srgbClr val="000000"/>
                   </a:solidFill>
@@ -4762,7 +4768,7 @@
           <a:p>
             <a:fld id="{48A87A34-81AB-432B-8DAE-1953F412C126}" type="datetimeFigureOut">
               <a:rPr lang="en-US" dirty="0"/>
-              <a:t>3/12/2026</a:t>
+              <a:t>3/16/2026</a:t>
             </a:fld>
             <a:endParaRPr lang="en-US" dirty="0"/>
           </a:p>
@@ -5024,7 +5030,7 @@
           <a:p>
             <a:fld id="{48A87A34-81AB-432B-8DAE-1953F412C126}" type="datetimeFigureOut">
               <a:rPr lang="en-US" dirty="0"/>
-              <a:t>3/12/2026</a:t>
+              <a:t>3/16/2026</a:t>
             </a:fld>
             <a:endParaRPr lang="en-US" dirty="0"/>
           </a:p>
@@ -5215,7 +5221,7 @@
           <a:p>
             <a:fld id="{48A87A34-81AB-432B-8DAE-1953F412C126}" type="datetimeFigureOut">
               <a:rPr lang="en-US" dirty="0"/>
-              <a:t>3/12/2026</a:t>
+              <a:t>3/16/2026</a:t>
             </a:fld>
             <a:endParaRPr lang="en-US" dirty="0"/>
           </a:p>
@@ -5473,7 +5479,7 @@
           <a:p>
             <a:fld id="{48A87A34-81AB-432B-8DAE-1953F412C126}" type="datetimeFigureOut">
               <a:rPr lang="en-US" dirty="0"/>
-              <a:t>3/12/2026</a:t>
+              <a:t>3/16/2026</a:t>
             </a:fld>
             <a:endParaRPr lang="en-US" dirty="0"/>
           </a:p>
@@ -5902,7 +5908,7 @@
           <a:p>
             <a:fld id="{48A87A34-81AB-432B-8DAE-1953F412C126}" type="datetimeFigureOut">
               <a:rPr lang="en-US" dirty="0"/>
-              <a:t>3/12/2026</a:t>
+              <a:t>3/16/2026</a:t>
             </a:fld>
             <a:endParaRPr lang="en-US" dirty="0"/>
           </a:p>
@@ -6443,7 +6449,7 @@
           <a:p>
             <a:fld id="{48A87A34-81AB-432B-8DAE-1953F412C126}" type="datetimeFigureOut">
               <a:rPr lang="en-US" dirty="0"/>
-              <a:t>3/12/2026</a:t>
+              <a:t>3/16/2026</a:t>
             </a:fld>
             <a:endParaRPr lang="en-US" dirty="0"/>
           </a:p>
@@ -7158,7 +7164,7 @@
           <a:p>
             <a:fld id="{48A87A34-81AB-432B-8DAE-1953F412C126}" type="datetimeFigureOut">
               <a:rPr lang="en-US" dirty="0"/>
-              <a:t>3/12/2026</a:t>
+              <a:t>3/16/2026</a:t>
             </a:fld>
             <a:endParaRPr lang="en-US" dirty="0"/>
           </a:p>
@@ -7323,7 +7329,7 @@
           <a:p>
             <a:fld id="{48A87A34-81AB-432B-8DAE-1953F412C126}" type="datetimeFigureOut">
               <a:rPr lang="en-US" dirty="0"/>
-              <a:t>3/12/2026</a:t>
+              <a:t>3/16/2026</a:t>
             </a:fld>
             <a:endParaRPr lang="en-US" dirty="0"/>
           </a:p>
@@ -7498,7 +7504,7 @@
           <a:p>
             <a:fld id="{48A87A34-81AB-432B-8DAE-1953F412C126}" type="datetimeFigureOut">
               <a:rPr lang="en-US" dirty="0"/>
-              <a:t>3/12/2026</a:t>
+              <a:t>3/16/2026</a:t>
             </a:fld>
             <a:endParaRPr lang="en-US" dirty="0"/>
           </a:p>
@@ -7663,7 +7669,7 @@
           <a:p>
             <a:fld id="{48A87A34-81AB-432B-8DAE-1953F412C126}" type="datetimeFigureOut">
               <a:rPr lang="en-US" dirty="0"/>
-              <a:t>3/12/2026</a:t>
+              <a:t>3/16/2026</a:t>
             </a:fld>
             <a:endParaRPr lang="en-US" dirty="0"/>
           </a:p>
@@ -7908,7 +7914,7 @@
           <a:p>
             <a:fld id="{48A87A34-81AB-432B-8DAE-1953F412C126}" type="datetimeFigureOut">
               <a:rPr lang="en-US" dirty="0"/>
-              <a:t>3/12/2026</a:t>
+              <a:t>3/16/2026</a:t>
             </a:fld>
             <a:endParaRPr lang="en-US" dirty="0"/>
           </a:p>
@@ -8135,7 +8141,7 @@
           <a:p>
             <a:fld id="{48A87A34-81AB-432B-8DAE-1953F412C126}" type="datetimeFigureOut">
               <a:rPr lang="en-US" dirty="0"/>
-              <a:t>3/12/2026</a:t>
+              <a:t>3/16/2026</a:t>
             </a:fld>
             <a:endParaRPr lang="en-US" dirty="0"/>
           </a:p>
@@ -8511,7 +8517,7 @@
           <a:p>
             <a:fld id="{48A87A34-81AB-432B-8DAE-1953F412C126}" type="datetimeFigureOut">
               <a:rPr lang="en-US" dirty="0"/>
-              <a:t>3/12/2026</a:t>
+              <a:t>3/16/2026</a:t>
             </a:fld>
             <a:endParaRPr lang="en-US" dirty="0"/>
           </a:p>
@@ -8624,7 +8630,7 @@
           <a:p>
             <a:fld id="{48A87A34-81AB-432B-8DAE-1953F412C126}" type="datetimeFigureOut">
               <a:rPr lang="en-US" dirty="0"/>
-              <a:t>3/12/2026</a:t>
+              <a:t>3/16/2026</a:t>
             </a:fld>
             <a:endParaRPr lang="en-US" dirty="0"/>
           </a:p>
@@ -8714,7 +8720,7 @@
           <a:p>
             <a:fld id="{48A87A34-81AB-432B-8DAE-1953F412C126}" type="datetimeFigureOut">
               <a:rPr lang="en-US" dirty="0"/>
-              <a:t>3/12/2026</a:t>
+              <a:t>3/16/2026</a:t>
             </a:fld>
             <a:endParaRPr lang="en-US" dirty="0"/>
           </a:p>
@@ -8958,7 +8964,7 @@
           <a:p>
             <a:fld id="{48A87A34-81AB-432B-8DAE-1953F412C126}" type="datetimeFigureOut">
               <a:rPr lang="en-US" dirty="0"/>
-              <a:t>3/12/2026</a:t>
+              <a:t>3/16/2026</a:t>
             </a:fld>
             <a:endParaRPr lang="en-US" dirty="0"/>
           </a:p>
@@ -9233,7 +9239,7 @@
           <a:p>
             <a:fld id="{48A87A34-81AB-432B-8DAE-1953F412C126}" type="datetimeFigureOut">
               <a:rPr lang="en-US" dirty="0"/>
-              <a:t>3/12/2026</a:t>
+              <a:t>3/16/2026</a:t>
             </a:fld>
             <a:endParaRPr lang="en-US" dirty="0"/>
           </a:p>
@@ -9344,7 +9350,7 @@
           <a:noFill/>
           <a:extLst>
             <a:ext uri="{909E8E84-426E-40dd-AFC4-6F175D3DCCD1}">
-              <a14:hiddenFill xmlns:a14="http://schemas.microsoft.com/office/drawing/2010/main" xmlns="">
+              <a14:hiddenFill xmlns="" xmlns:a14="http://schemas.microsoft.com/office/drawing/2010/main">
                 <a:solidFill>
                   <a:srgbClr val="FFFFFF"/>
                 </a:solidFill>
@@ -9418,7 +9424,7 @@
               </a:ln>
               <a:extLst>
                 <a:ext uri="{91240B29-F687-4f45-9708-019B960494DF}">
-                  <a14:hiddenLine xmlns:a14="http://schemas.microsoft.com/office/drawing/2010/main" xmlns="" w="9525">
+                  <a14:hiddenLine xmlns="" xmlns:a14="http://schemas.microsoft.com/office/drawing/2010/main" w="9525">
                     <a:solidFill>
                       <a:srgbClr val="000000"/>
                     </a:solidFill>
@@ -9515,7 +9521,7 @@
               </a:ln>
               <a:extLst>
                 <a:ext uri="{91240B29-F687-4f45-9708-019B960494DF}">
-                  <a14:hiddenLine xmlns:a14="http://schemas.microsoft.com/office/drawing/2010/main" xmlns="" w="9525">
+                  <a14:hiddenLine xmlns="" xmlns:a14="http://schemas.microsoft.com/office/drawing/2010/main" w="9525">
                     <a:solidFill>
                       <a:srgbClr val="000000"/>
                     </a:solidFill>
@@ -9612,7 +9618,7 @@
               </a:ln>
               <a:extLst>
                 <a:ext uri="{91240B29-F687-4f45-9708-019B960494DF}">
-                  <a14:hiddenLine xmlns:a14="http://schemas.microsoft.com/office/drawing/2010/main" xmlns="" w="9525">
+                  <a14:hiddenLine xmlns="" xmlns:a14="http://schemas.microsoft.com/office/drawing/2010/main" w="9525">
                     <a:solidFill>
                       <a:srgbClr val="000000"/>
                     </a:solidFill>
@@ -9681,7 +9687,7 @@
               </a:ln>
               <a:extLst>
                 <a:ext uri="{91240B29-F687-4f45-9708-019B960494DF}">
-                  <a14:hiddenLine xmlns:a14="http://schemas.microsoft.com/office/drawing/2010/main" xmlns="" w="9525">
+                  <a14:hiddenLine xmlns="" xmlns:a14="http://schemas.microsoft.com/office/drawing/2010/main" w="9525">
                     <a:solidFill>
                       <a:srgbClr val="000000"/>
                     </a:solidFill>
@@ -9778,7 +9784,7 @@
               </a:ln>
               <a:extLst>
                 <a:ext uri="{91240B29-F687-4f45-9708-019B960494DF}">
-                  <a14:hiddenLine xmlns:a14="http://schemas.microsoft.com/office/drawing/2010/main" xmlns="" w="9525">
+                  <a14:hiddenLine xmlns="" xmlns:a14="http://schemas.microsoft.com/office/drawing/2010/main" w="9525">
                     <a:solidFill>
                       <a:srgbClr val="000000"/>
                     </a:solidFill>
@@ -9847,7 +9853,7 @@
               </a:ln>
               <a:extLst>
                 <a:ext uri="{91240B29-F687-4f45-9708-019B960494DF}">
-                  <a14:hiddenLine xmlns:a14="http://schemas.microsoft.com/office/drawing/2010/main" xmlns="" w="9525">
+                  <a14:hiddenLine xmlns="" xmlns:a14="http://schemas.microsoft.com/office/drawing/2010/main" w="9525">
                     <a:solidFill>
                       <a:srgbClr val="000000"/>
                     </a:solidFill>
@@ -9916,7 +9922,7 @@
               </a:ln>
               <a:extLst>
                 <a:ext uri="{91240B29-F687-4f45-9708-019B960494DF}">
-                  <a14:hiddenLine xmlns:a14="http://schemas.microsoft.com/office/drawing/2010/main" xmlns="" w="9525">
+                  <a14:hiddenLine xmlns="" xmlns:a14="http://schemas.microsoft.com/office/drawing/2010/main" w="9525">
                     <a:solidFill>
                       <a:srgbClr val="000000"/>
                     </a:solidFill>
@@ -10013,7 +10019,7 @@
               </a:ln>
               <a:extLst>
                 <a:ext uri="{91240B29-F687-4f45-9708-019B960494DF}">
-                  <a14:hiddenLine xmlns:a14="http://schemas.microsoft.com/office/drawing/2010/main" xmlns="" w="9525">
+                  <a14:hiddenLine xmlns="" xmlns:a14="http://schemas.microsoft.com/office/drawing/2010/main" w="9525">
                     <a:solidFill>
                       <a:srgbClr val="000000"/>
                     </a:solidFill>
@@ -10110,7 +10116,7 @@
               </a:ln>
               <a:extLst>
                 <a:ext uri="{91240B29-F687-4f45-9708-019B960494DF}">
-                  <a14:hiddenLine xmlns:a14="http://schemas.microsoft.com/office/drawing/2010/main" xmlns="" w="9525">
+                  <a14:hiddenLine xmlns="" xmlns:a14="http://schemas.microsoft.com/office/drawing/2010/main" w="9525">
                     <a:solidFill>
                       <a:srgbClr val="000000"/>
                     </a:solidFill>
@@ -10179,7 +10185,7 @@
               </a:ln>
               <a:extLst>
                 <a:ext uri="{91240B29-F687-4f45-9708-019B960494DF}">
-                  <a14:hiddenLine xmlns:a14="http://schemas.microsoft.com/office/drawing/2010/main" xmlns="" w="9525">
+                  <a14:hiddenLine xmlns="" xmlns:a14="http://schemas.microsoft.com/office/drawing/2010/main" w="9525">
                     <a:solidFill>
                       <a:srgbClr val="000000"/>
                     </a:solidFill>
@@ -10296,7 +10302,7 @@
               </a:ln>
               <a:extLst>
                 <a:ext uri="{91240B29-F687-4f45-9708-019B960494DF}">
-                  <a14:hiddenLine xmlns:a14="http://schemas.microsoft.com/office/drawing/2010/main" xmlns="" w="9525">
+                  <a14:hiddenLine xmlns="" xmlns:a14="http://schemas.microsoft.com/office/drawing/2010/main" w="9525">
                     <a:solidFill>
                       <a:srgbClr val="000000"/>
                     </a:solidFill>
@@ -10394,7 +10400,7 @@
               </a:ln>
               <a:extLst>
                 <a:ext uri="{91240B29-F687-4f45-9708-019B960494DF}">
-                  <a14:hiddenLine xmlns:a14="http://schemas.microsoft.com/office/drawing/2010/main" xmlns="" w="9525">
+                  <a14:hiddenLine xmlns="" xmlns:a14="http://schemas.microsoft.com/office/drawing/2010/main" w="9525">
                     <a:solidFill>
                       <a:srgbClr val="000000"/>
                     </a:solidFill>
@@ -10463,7 +10469,7 @@
               </a:ln>
               <a:extLst>
                 <a:ext uri="{91240B29-F687-4f45-9708-019B960494DF}">
-                  <a14:hiddenLine xmlns:a14="http://schemas.microsoft.com/office/drawing/2010/main" xmlns="" w="9525">
+                  <a14:hiddenLine xmlns="" xmlns:a14="http://schemas.microsoft.com/office/drawing/2010/main" w="9525">
                     <a:solidFill>
                       <a:srgbClr val="000000"/>
                     </a:solidFill>
@@ -10532,7 +10538,7 @@
               </a:ln>
               <a:extLst>
                 <a:ext uri="{91240B29-F687-4f45-9708-019B960494DF}">
-                  <a14:hiddenLine xmlns:a14="http://schemas.microsoft.com/office/drawing/2010/main" xmlns="" w="9525">
+                  <a14:hiddenLine xmlns="" xmlns:a14="http://schemas.microsoft.com/office/drawing/2010/main" w="9525">
                     <a:solidFill>
                       <a:srgbClr val="000000"/>
                     </a:solidFill>
@@ -10629,7 +10635,7 @@
               </a:ln>
               <a:extLst>
                 <a:ext uri="{91240B29-F687-4f45-9708-019B960494DF}">
-                  <a14:hiddenLine xmlns:a14="http://schemas.microsoft.com/office/drawing/2010/main" xmlns="" w="9525">
+                  <a14:hiddenLine xmlns="" xmlns:a14="http://schemas.microsoft.com/office/drawing/2010/main" w="9525">
                     <a:solidFill>
                       <a:srgbClr val="000000"/>
                     </a:solidFill>
@@ -10670,7 +10676,7 @@
               </a:ln>
               <a:extLst>
                 <a:ext uri="{91240B29-F687-4f45-9708-019B960494DF}">
-                  <a14:hiddenLine xmlns:a14="http://schemas.microsoft.com/office/drawing/2010/main" xmlns="" w="9525">
+                  <a14:hiddenLine xmlns="" xmlns:a14="http://schemas.microsoft.com/office/drawing/2010/main" w="9525">
                     <a:solidFill>
                       <a:srgbClr val="000000"/>
                     </a:solidFill>
@@ -10742,7 +10748,7 @@
               </a:ln>
               <a:extLst>
                 <a:ext uri="{91240B29-F687-4f45-9708-019B960494DF}">
-                  <a14:hiddenLine xmlns:a14="http://schemas.microsoft.com/office/drawing/2010/main" xmlns="" w="9525">
+                  <a14:hiddenLine xmlns="" xmlns:a14="http://schemas.microsoft.com/office/drawing/2010/main" w="9525">
                     <a:solidFill>
                       <a:srgbClr val="000000"/>
                     </a:solidFill>
@@ -10839,7 +10845,7 @@
               </a:ln>
               <a:extLst>
                 <a:ext uri="{91240B29-F687-4f45-9708-019B960494DF}">
-                  <a14:hiddenLine xmlns:a14="http://schemas.microsoft.com/office/drawing/2010/main" xmlns="" w="9525">
+                  <a14:hiddenLine xmlns="" xmlns:a14="http://schemas.microsoft.com/office/drawing/2010/main" w="9525">
                     <a:solidFill>
                       <a:srgbClr val="000000"/>
                     </a:solidFill>
@@ -10908,7 +10914,7 @@
               </a:ln>
               <a:extLst>
                 <a:ext uri="{91240B29-F687-4f45-9708-019B960494DF}">
-                  <a14:hiddenLine xmlns:a14="http://schemas.microsoft.com/office/drawing/2010/main" xmlns="" w="9525">
+                  <a14:hiddenLine xmlns="" xmlns:a14="http://schemas.microsoft.com/office/drawing/2010/main" w="9525">
                     <a:solidFill>
                       <a:srgbClr val="000000"/>
                     </a:solidFill>
@@ -11005,7 +11011,7 @@
               </a:ln>
               <a:extLst>
                 <a:ext uri="{91240B29-F687-4f45-9708-019B960494DF}">
-                  <a14:hiddenLine xmlns:a14="http://schemas.microsoft.com/office/drawing/2010/main" xmlns="" w="9525">
+                  <a14:hiddenLine xmlns="" xmlns:a14="http://schemas.microsoft.com/office/drawing/2010/main" w="9525">
                     <a:solidFill>
                       <a:srgbClr val="000000"/>
                     </a:solidFill>
@@ -11077,7 +11083,7 @@
               </a:ln>
               <a:extLst>
                 <a:ext uri="{91240B29-F687-4f45-9708-019B960494DF}">
-                  <a14:hiddenLine xmlns:a14="http://schemas.microsoft.com/office/drawing/2010/main" xmlns="" w="9525">
+                  <a14:hiddenLine xmlns="" xmlns:a14="http://schemas.microsoft.com/office/drawing/2010/main" w="9525">
                     <a:solidFill>
                       <a:srgbClr val="000000"/>
                     </a:solidFill>
@@ -11146,7 +11152,7 @@
               </a:ln>
               <a:extLst>
                 <a:ext uri="{91240B29-F687-4f45-9708-019B960494DF}">
-                  <a14:hiddenLine xmlns:a14="http://schemas.microsoft.com/office/drawing/2010/main" xmlns="" w="9525">
+                  <a14:hiddenLine xmlns="" xmlns:a14="http://schemas.microsoft.com/office/drawing/2010/main" w="9525">
                     <a:solidFill>
                       <a:srgbClr val="000000"/>
                     </a:solidFill>
@@ -11243,7 +11249,7 @@
               </a:ln>
               <a:extLst>
                 <a:ext uri="{91240B29-F687-4f45-9708-019B960494DF}">
-                  <a14:hiddenLine xmlns:a14="http://schemas.microsoft.com/office/drawing/2010/main" xmlns="" w="9525">
+                  <a14:hiddenLine xmlns="" xmlns:a14="http://schemas.microsoft.com/office/drawing/2010/main" w="9525">
                     <a:solidFill>
                       <a:srgbClr val="000000"/>
                     </a:solidFill>
@@ -11340,7 +11346,7 @@
               </a:ln>
               <a:extLst>
                 <a:ext uri="{91240B29-F687-4f45-9708-019B960494DF}">
-                  <a14:hiddenLine xmlns:a14="http://schemas.microsoft.com/office/drawing/2010/main" xmlns="" w="9525">
+                  <a14:hiddenLine xmlns="" xmlns:a14="http://schemas.microsoft.com/office/drawing/2010/main" w="9525">
                     <a:solidFill>
                       <a:srgbClr val="000000"/>
                     </a:solidFill>
@@ -11412,7 +11418,7 @@
               </a:ln>
               <a:extLst>
                 <a:ext uri="{91240B29-F687-4f45-9708-019B960494DF}">
-                  <a14:hiddenLine xmlns:a14="http://schemas.microsoft.com/office/drawing/2010/main" xmlns="" w="9525">
+                  <a14:hiddenLine xmlns="" xmlns:a14="http://schemas.microsoft.com/office/drawing/2010/main" w="9525">
                     <a:solidFill>
                       <a:srgbClr val="000000"/>
                     </a:solidFill>
@@ -11539,7 +11545,7 @@
               </a:ln>
               <a:extLst>
                 <a:ext uri="{91240B29-F687-4f45-9708-019B960494DF}">
-                  <a14:hiddenLine xmlns:a14="http://schemas.microsoft.com/office/drawing/2010/main" xmlns="" w="9525">
+                  <a14:hiddenLine xmlns="" xmlns:a14="http://schemas.microsoft.com/office/drawing/2010/main" w="9525">
                     <a:solidFill>
                       <a:srgbClr val="000000"/>
                     </a:solidFill>
@@ -11644,7 +11650,7 @@
               </a:ln>
               <a:extLst>
                 <a:ext uri="{91240B29-F687-4f45-9708-019B960494DF}">
-                  <a14:hiddenLine xmlns:a14="http://schemas.microsoft.com/office/drawing/2010/main" xmlns="" w="9525">
+                  <a14:hiddenLine xmlns="" xmlns:a14="http://schemas.microsoft.com/office/drawing/2010/main" w="9525">
                     <a:solidFill>
                       <a:srgbClr val="000000"/>
                     </a:solidFill>
@@ -11766,7 +11772,7 @@
               </a:ln>
               <a:extLst>
                 <a:ext uri="{91240B29-F687-4f45-9708-019B960494DF}">
-                  <a14:hiddenLine xmlns:a14="http://schemas.microsoft.com/office/drawing/2010/main" xmlns="" w="9525">
+                  <a14:hiddenLine xmlns="" xmlns:a14="http://schemas.microsoft.com/office/drawing/2010/main" w="9525">
                     <a:solidFill>
                       <a:srgbClr val="000000"/>
                     </a:solidFill>
@@ -11863,7 +11869,7 @@
               </a:ln>
               <a:extLst>
                 <a:ext uri="{91240B29-F687-4f45-9708-019B960494DF}">
-                  <a14:hiddenLine xmlns:a14="http://schemas.microsoft.com/office/drawing/2010/main" xmlns="" w="9525">
+                  <a14:hiddenLine xmlns="" xmlns:a14="http://schemas.microsoft.com/office/drawing/2010/main" w="9525">
                     <a:solidFill>
                       <a:srgbClr val="000000"/>
                     </a:solidFill>
@@ -11935,7 +11941,7 @@
               </a:ln>
               <a:extLst>
                 <a:ext uri="{91240B29-F687-4f45-9708-019B960494DF}">
-                  <a14:hiddenLine xmlns:a14="http://schemas.microsoft.com/office/drawing/2010/main" xmlns="" w="9525">
+                  <a14:hiddenLine xmlns="" xmlns:a14="http://schemas.microsoft.com/office/drawing/2010/main" w="9525">
                     <a:solidFill>
                       <a:srgbClr val="000000"/>
                     </a:solidFill>
@@ -12032,7 +12038,7 @@
               </a:ln>
               <a:extLst>
                 <a:ext uri="{91240B29-F687-4f45-9708-019B960494DF}">
-                  <a14:hiddenLine xmlns:a14="http://schemas.microsoft.com/office/drawing/2010/main" xmlns="" w="9525">
+                  <a14:hiddenLine xmlns="" xmlns:a14="http://schemas.microsoft.com/office/drawing/2010/main" w="9525">
                     <a:solidFill>
                       <a:srgbClr val="000000"/>
                     </a:solidFill>
@@ -12107,7 +12113,7 @@
               </a:ln>
               <a:extLst>
                 <a:ext uri="{91240B29-F687-4f45-9708-019B960494DF}">
-                  <a14:hiddenLine xmlns:a14="http://schemas.microsoft.com/office/drawing/2010/main" xmlns="" w="9525">
+                  <a14:hiddenLine xmlns="" xmlns:a14="http://schemas.microsoft.com/office/drawing/2010/main" w="9525">
                     <a:solidFill>
                       <a:srgbClr val="000000"/>
                     </a:solidFill>
@@ -12204,7 +12210,7 @@
               </a:ln>
               <a:extLst>
                 <a:ext uri="{91240B29-F687-4f45-9708-019B960494DF}">
-                  <a14:hiddenLine xmlns:a14="http://schemas.microsoft.com/office/drawing/2010/main" xmlns="" w="9525">
+                  <a14:hiddenLine xmlns="" xmlns:a14="http://schemas.microsoft.com/office/drawing/2010/main" w="9525">
                     <a:solidFill>
                       <a:srgbClr val="000000"/>
                     </a:solidFill>
@@ -12279,7 +12285,7 @@
               </a:ln>
               <a:extLst>
                 <a:ext uri="{91240B29-F687-4f45-9708-019B960494DF}">
-                  <a14:hiddenLine xmlns:a14="http://schemas.microsoft.com/office/drawing/2010/main" xmlns="" w="9525">
+                  <a14:hiddenLine xmlns="" xmlns:a14="http://schemas.microsoft.com/office/drawing/2010/main" w="9525">
                     <a:solidFill>
                       <a:srgbClr val="000000"/>
                     </a:solidFill>
@@ -12376,7 +12382,7 @@
               </a:ln>
               <a:extLst>
                 <a:ext uri="{91240B29-F687-4f45-9708-019B960494DF}">
-                  <a14:hiddenLine xmlns:a14="http://schemas.microsoft.com/office/drawing/2010/main" xmlns="" w="9525">
+                  <a14:hiddenLine xmlns="" xmlns:a14="http://schemas.microsoft.com/office/drawing/2010/main" w="9525">
                     <a:solidFill>
                       <a:srgbClr val="000000"/>
                     </a:solidFill>
@@ -12417,7 +12423,7 @@
               </a:ln>
               <a:extLst>
                 <a:ext uri="{91240B29-F687-4f45-9708-019B960494DF}">
-                  <a14:hiddenLine xmlns:a14="http://schemas.microsoft.com/office/drawing/2010/main" xmlns="" w="9525">
+                  <a14:hiddenLine xmlns="" xmlns:a14="http://schemas.microsoft.com/office/drawing/2010/main" w="9525">
                     <a:solidFill>
                       <a:srgbClr val="000000"/>
                     </a:solidFill>
@@ -12565,7 +12571,7 @@
             <a:fld id="{48A87A34-81AB-432B-8DAE-1953F412C126}" type="datetimeFigureOut">
               <a:rPr lang="en-US" dirty="0"/>
               <a:pPr/>
-              <a:t>3/12/2026</a:t>
+              <a:t>3/16/2026</a:t>
             </a:fld>
             <a:endParaRPr lang="en-US" dirty="0"/>
           </a:p>
@@ -13132,7 +13138,10 @@
           <a:bodyPr/>
           <a:lstStyle/>
           <a:p>
-            <a:endParaRPr lang="nl-NL"/>
+            <a:r>
+              <a:rPr lang="nl-NL" dirty="0"/>
+              <a:t>agenda</a:t>
+            </a:r>
           </a:p>
         </p:txBody>
       </p:sp>
@@ -13157,7 +13166,22 @@
           <a:bodyPr/>
           <a:lstStyle/>
           <a:p>
-            <a:endParaRPr lang="nl-NL"/>
+            <a:r>
+              <a:rPr lang="nl-NL" dirty="0"/>
+              <a:t>1:  Dialoog manager</a:t>
+            </a:r>
+          </a:p>
+          <a:p>
+            <a:r>
+              <a:rPr lang="nl-NL" dirty="0"/>
+              <a:t>2:  Script runner</a:t>
+            </a:r>
+          </a:p>
+          <a:p>
+            <a:r>
+              <a:rPr lang="nl-NL" dirty="0"/>
+              <a:t>3:  Vragen</a:t>
+            </a:r>
           </a:p>
         </p:txBody>
       </p:sp>
@@ -13165,6 +13189,136 @@
     <p:extLst>
       <p:ext uri="{BB962C8B-B14F-4D97-AF65-F5344CB8AC3E}">
         <p14:creationId xmlns:p14="http://schemas.microsoft.com/office/powerpoint/2010/main" val="3720985603"/>
+      </p:ext>
+    </p:extLst>
+  </p:cSld>
+  <p:clrMapOvr>
+    <a:masterClrMapping/>
+  </p:clrMapOvr>
+</p:sld>
+</file>
+
+<file path=ppt/slides/slide3.xml><?xml version="1.0" encoding="utf-8"?>
+<p:sld xmlns:a="http://schemas.openxmlformats.org/drawingml/2006/main" xmlns:r="http://schemas.openxmlformats.org/officeDocument/2006/relationships" xmlns:p="http://schemas.openxmlformats.org/presentationml/2006/main">
+  <p:cSld>
+    <p:spTree>
+      <p:nvGrpSpPr>
+        <p:cNvPr id="1" name="">
+          <a:extLst>
+            <a:ext uri="{FF2B5EF4-FFF2-40B4-BE49-F238E27FC236}">
+              <a16:creationId xmlns:a16="http://schemas.microsoft.com/office/drawing/2014/main" id="{D48C3DB7-B448-21A0-A3B7-ED702F5ED255}"/>
+            </a:ext>
+          </a:extLst>
+        </p:cNvPr>
+        <p:cNvGrpSpPr/>
+        <p:nvPr/>
+      </p:nvGrpSpPr>
+      <p:grpSpPr>
+        <a:xfrm>
+          <a:off x="0" y="0"/>
+          <a:ext cx="0" cy="0"/>
+          <a:chOff x="0" y="0"/>
+          <a:chExt cx="0" cy="0"/>
+        </a:xfrm>
+      </p:grpSpPr>
+      <p:sp>
+        <p:nvSpPr>
+          <p:cNvPr id="2" name="Titel 1">
+            <a:extLst>
+              <a:ext uri="{FF2B5EF4-FFF2-40B4-BE49-F238E27FC236}">
+                <a16:creationId xmlns:a16="http://schemas.microsoft.com/office/drawing/2014/main" id="{DED5E6DE-3513-FC91-D25B-4368D0DDF80D}"/>
+              </a:ext>
+            </a:extLst>
+          </p:cNvPr>
+          <p:cNvSpPr>
+            <a:spLocks noGrp="1"/>
+          </p:cNvSpPr>
+          <p:nvPr>
+            <p:ph type="title"/>
+          </p:nvPr>
+        </p:nvSpPr>
+        <p:spPr/>
+        <p:txBody>
+          <a:bodyPr/>
+          <a:lstStyle/>
+          <a:p>
+            <a:r>
+              <a:rPr lang="nl-NL" strike="sngStrike" dirty="0"/>
+              <a:t>agenda</a:t>
+            </a:r>
+          </a:p>
+        </p:txBody>
+      </p:sp>
+      <p:sp>
+        <p:nvSpPr>
+          <p:cNvPr id="3" name="Tijdelijke aanduiding voor inhoud 2">
+            <a:extLst>
+              <a:ext uri="{FF2B5EF4-FFF2-40B4-BE49-F238E27FC236}">
+                <a16:creationId xmlns:a16="http://schemas.microsoft.com/office/drawing/2014/main" id="{F9BEAAF3-D41C-094F-760B-13460B1A967B}"/>
+              </a:ext>
+            </a:extLst>
+          </p:cNvPr>
+          <p:cNvSpPr>
+            <a:spLocks noGrp="1"/>
+          </p:cNvSpPr>
+          <p:nvPr>
+            <p:ph idx="1"/>
+          </p:nvPr>
+        </p:nvSpPr>
+        <p:spPr/>
+        <p:txBody>
+          <a:bodyPr/>
+          <a:lstStyle/>
+          <a:p>
+            <a:r>
+              <a:rPr lang="nl-NL" dirty="0"/>
+              <a:t>Alex runs </a:t>
+            </a:r>
+            <a:r>
+              <a:rPr lang="nl-NL" dirty="0" err="1"/>
+              <a:t>the</a:t>
+            </a:r>
+            <a:r>
+              <a:rPr lang="nl-NL" dirty="0"/>
+              <a:t> show</a:t>
+            </a:r>
+          </a:p>
+        </p:txBody>
+      </p:sp>
+      <p:pic>
+        <p:nvPicPr>
+          <p:cNvPr id="4" name="Afbeelding 3">
+            <a:extLst>
+              <a:ext uri="{FF2B5EF4-FFF2-40B4-BE49-F238E27FC236}">
+                <a16:creationId xmlns:a16="http://schemas.microsoft.com/office/drawing/2014/main" id="{BA556894-A748-ECC1-FC75-9F78B7A3DDF7}"/>
+              </a:ext>
+            </a:extLst>
+          </p:cNvPr>
+          <p:cNvPicPr>
+            <a:picLocks noChangeAspect="1"/>
+          </p:cNvPicPr>
+          <p:nvPr/>
+        </p:nvPicPr>
+        <p:blipFill>
+          <a:blip r:embed="rId2"/>
+          <a:stretch>
+            <a:fillRect/>
+          </a:stretch>
+        </p:blipFill>
+        <p:spPr>
+          <a:xfrm rot="447303">
+            <a:off x="6272211" y="0"/>
+            <a:ext cx="5143500" cy="6858000"/>
+          </a:xfrm>
+          <a:prstGeom prst="rect">
+            <a:avLst/>
+          </a:prstGeom>
+        </p:spPr>
+      </p:pic>
+    </p:spTree>
+    <p:extLst>
+      <p:ext uri="{BB962C8B-B14F-4D97-AF65-F5344CB8AC3E}">
+        <p14:creationId xmlns:p14="http://schemas.microsoft.com/office/powerpoint/2010/main" val="358609520"/>
       </p:ext>
     </p:extLst>
   </p:cSld>

</xml_diff>